<commit_message>
Refine progress report wording and shorten English speaker notes
</commit_message>
<xml_diff>
--- a/presentations/progress_report/Jordan_Sorting_Progress_Report.pptx
+++ b/presentations/progress_report/Jordan_Sorting_Progress_Report.pptx
@@ -557,7 +557,7 @@
           <a:lstStyle xmlns:a="http://schemas.openxmlformats.org/drawingml/2006/main"/>
           <a:p xmlns:a="http://schemas.openxmlformats.org/drawingml/2006/main">
             <a:r>
-              <a:t>Correct insertion also requires consistent ownership. Every finite pair has one parent and one sibling-list owner. Before a split, the existing owner controls both the retained and acquired segments. After the split, the existing owner keeps the retained segment, and the new owner receives the acquired segment. The implementation may create new sibling lists for both nonempty sides. Their list identifiers can therefore change. Only the acquired segment changes parent ownership. The code treats the split and transfer as one transaction. It saves the affected state, performs the update, and checks the split boundary, ownership, and local postconditions. If a check fails, it restores the old registry, ownership links, and list identifiers. The maintained state also contains the sorted processed prefix and both pair families. Ordinary lists make scanning, copying, slicing, and ownership rebinding visible costs. These checks protect correctness, but they do not provide the update bounds used in the historical linear-time analysis.</a:t>
+              <a:t>Correct insertion also requires consistent ownership. Every finite pair has one parent and one sibling-list owner. Before a split, the existing owner controls both the retained and acquired segments. After the split, the existing owner keeps the retained segment, and the new owner receives the acquired segment. The split may create new lists for both nonempty sides, but only the acquired segment changes parent. The code treats the split and transfer as one transaction. It saves the affected state, performs the update, and checks the split boundary, ownership, and local postconditions. If a check fails, it restores the old registry, ownership links, and list identifiers. The maintained state also contains the sorted processed prefix and both pair families. Ordinary lists make scanning, copying, slicing, and ownership rebinding visible costs. These checks protect correctness, but they do not provide the update bounds used in the historical linear-time analysis.</a:t>
             </a:r>
           </a:p>
           <a:p xmlns:a="http://schemas.openxmlformats.org/drawingml/2006/main">
@@ -952,7 +952,7 @@
           <a:lstStyle xmlns:a="http://schemas.openxmlformats.org/drawingml/2006/main"/>
           <a:p xmlns:a="http://schemas.openxmlformats.org/drawingml/2006/main">
             <a:r>
-              <a:t>The main runtime pattern is the decrease in the paper/reference ratio across the five tested sizes. I first compute the ratio for each exact case. Each case then has equal weight in the size-level median. The ratio is 3.226 at n equals 32, 2.202 at 64, and 1.351 at 128. It falls below one at 256, where it is 0.851, and reaches 0.567 at 512. The observed crossover lies between the tested sizes 128 and 256. The pilot experiment showed the same downward direction, although I do not combine absolute times across the two runs. Under these timing scopes, the recorded paper call is smaller than the reference-pipeline call at the two larger sizes. The scopes differ, so this pattern does not establish a general speedup. Five sizes also do not establish asymptotic behavior. Python sort, shown in Backup A, has the lowest median call time at every tested size.</a:t>
+              <a:t>The main runtime pattern is the decrease in the paper/reference ratio across the five tested sizes. I first compute the ratio for each exact case. Each case then has equal weight in the size-level median. The ratio is 3.226 at n equals 32, 2.202 at 64, and 1.351 at 128. It falls below one at 256, where it is 0.851, and reaches 0.567 at 512. The observed crossover lies between the tested sizes 128 and 256. Under these timing scopes, the recorded paper call is smaller than the reference-pipeline call at the two larger sizes. The scopes differ, so this pattern does not establish a general speedup. Five sizes also do not establish asymptotic behavior. Python sort, shown in Backup A, has the lowest median call time at every tested size.</a:t>
             </a:r>
           </a:p>
           <a:p xmlns:a="http://schemas.openxmlformats.org/drawingml/2006/main">
@@ -1142,7 +1142,7 @@
           <a:lstStyle xmlns:a="http://schemas.openxmlformats.org/drawingml/2006/main"/>
           <a:p xmlns:a="http://schemas.openxmlformats.org/drawingml/2006/main">
             <a:r>
-              <a:t>A possible next step is to investigate a finger-tree backend while keeping the same Step 1, Step 2, and Step 3 behavior. The ordinary-list implementation gives a tested reference point for that work. The detailed backend boundary appears in Backup E, including the ownership-transfer difficulty. I would like guidance on two questions. First, should the extension target the historical heterogeneous finger tree, or an equivalent backend with the required list operations? Second, would semantic equivalence and an experimental comparison be sufficient, or should the thesis also include an amortized operation-bound argument? This choice determines whether the extension remains mainly experimental or also requires a proof-level component.</a:t>
+              <a:t>A possible next step is to investigate a finger-tree backend while keeping the same Step 1, Step 2, and Step 3 behavior. The ordinary-list implementation gives a tested reference point for that work. The detailed backend boundary appears in Backup E, including the ownership-transfer difficulty. I would like guidance on two questions. First, should the extension target the historical heterogeneous finger tree, or an equivalent backend with the required list operations? Second, is a tested, semantically equivalent prototype enough, or should I also prove the required amortized operation bounds? The answer determines whether this stays an implementation experiment or also needs a complexity proof.</a:t>
             </a:r>
           </a:p>
           <a:p xmlns:a="http://schemas.openxmlformats.org/drawingml/2006/main">
@@ -1822,7 +1822,7 @@
           <a:lstStyle xmlns:a="http://schemas.openxmlformats.org/drawingml/2006/main"/>
           <a:p xmlns:a="http://schemas.openxmlformats.org/drawingml/2006/main">
             <a:r>
-              <a:t>Since the previous report, I have worked on four areas. I first narrowed the scope to sorting inputs that an external oracle has already certified. I then implemented the Step 1, Step 2, and Step 3 control flow. Next, I added ownership checks, transactional updates, replay, and bounded validation. Finally, after the implementation was working and checked, I ran a formal experiment with a fixed protocol. These areas depend on each other. The experiment only became meaningful after the output source and state checks were clear. The result is an executable ordinary-list implementation. The specialized backend used in the historical linear-time analysis remains future work.</a:t>
+              <a:t>Since the previous report, I have worked on four areas. I first narrowed the scope to sorting inputs that an external oracle has already certified. I then implemented the Step 1, Step 2, and Step 3 control flow. Next, I added ownership checks, transactional updates, replay, and bounded validation. Finally, after the implementation was working and checked, I ran a formal experiment with a fixed protocol. The result is an executable ordinary-list implementation. The specialized backend used in the historical linear-time analysis remains future work.</a:t>
             </a:r>
           </a:p>
           <a:p xmlns:a="http://schemas.openxmlformats.org/drawingml/2006/main">
@@ -2297,7 +2297,7 @@
           <a:lstStyle xmlns:a="http://schemas.openxmlformats.org/drawingml/2006/main"/>
           <a:p xmlns:a="http://schemas.openxmlformats.org/drawingml/2006/main">
             <a:r>
-              <a:t>The first issue concerns the endpoint used in Step 3(c). Consider the valid prefix three, two, one, four. The acquired pair P two is stored in curve order as three, two. A mechanical reading might choose the second stored element, two, as the insertion anchor. That produces one, two, four, three, which is wrong on the axis. Curve order and axis order describe different things. The pair records traversal along the curve, while Step 3(c) needs the geometric extreme on the axis. Here the correct endpoint is three. Inserting four after three gives one, two, three, four. The example exposes a representation issue rather than a special case for these four values. The stored pair order follows the curve, so its second item does not always represent the required side of the current axis order. The increasing orientation uses the right geometric endpoint, and the decreasing orientation uses the left endpoint. The rule therefore selects the geometric extreme rather than the second stored element. I describe this as an executable clarification because the 1990 paper does not state it in this form. Without the clarification, valid examples fail.</a:t>
+              <a:t>The first issue concerns the endpoint used in Step 3(c). Consider the valid prefix three, two, one, four. The acquired pair P two is stored in curve order as three, two. A mechanical reading might choose the second stored element, two, as the insertion anchor. That produces one, two, four, three, which is wrong on the axis. Curve order and axis order describe different things. The pair records traversal along the curve, while Step 3(c) needs the geometric extreme on the axis. Here the correct endpoint is three. Inserting four after three gives one, two, three, four. This is a representation issue, not a special case for these four numbers. The stored pair order follows the curve, so its second item does not always represent the required side of the current axis order. The increasing orientation uses the right geometric endpoint, and the decreasing orientation uses the left endpoint. I describe this as an executable clarification because the 1990 paper does not state it in this form. Without the clarification, valid examples fail.</a:t>
             </a:r>
           </a:p>
           <a:p xmlns:a="http://schemas.openxmlformats.org/drawingml/2006/main">
@@ -2387,7 +2387,7 @@
           <a:lstStyle xmlns:a="http://schemas.openxmlformats.org/drawingml/2006/main"/>
           <a:p xmlns:a="http://schemas.openxmlformats.org/drawingml/2006/main">
             <a:r>
-              <a:t>The second issue is the odd-index z one case. The valid prefix here is one, two, three, four, six, seven, zero. During this decreasing iteration, the ordinary geometric base anchor is z two, with value two. Inserting zero directly before z two gives one, zero, two, three, four, six, seven. Z one remains on the wrong side of the new point. Because zero is smaller than z one, and z one is smaller than the original anchor, the output anchor changes from z two to z one. Inserting zero before z one gives the correct order. The important point is that this change affects the output insertion only. It does not replace the earlier predecessor or successor boundary calculation. Those two decisions solve different problems. One selects the pair used by the family update. The other selects the point used to update the output order. The implementation records both decisions separately, which also makes the diagnostic trace easier to check.</a:t>
+              <a:t>The second issue is the odd-index z one case. The valid prefix here is one, two, three, four, six, seven, zero. During this decreasing iteration, the ordinary geometric base anchor is z two, with value two. Inserting zero directly before z two gives one, zero, two, three, four, six, seven. Z one remains on the wrong side of the new point. Zero is smaller than z one. Z one is also smaller than the original anchor. Therefore, the output anchor changes from z two to z one. Inserting zero before z one gives the correct order. The important point is that this change affects the output insertion only. It does not replace the earlier predecessor or successor boundary calculation. Those two decisions solve different problems. One selects the pair used by the family update. The other selects the point used to update the output order. The implementation records both decisions separately, which also makes the diagnostic trace easier to check.</a:t>
             </a:r>
           </a:p>
           <a:p xmlns:a="http://schemas.openxmlformats.org/drawingml/2006/main">
@@ -3588,7 +3588,7 @@
                   <a:srgbClr val="D9EAF2"/>
                 </a:solidFill>
               </a:rPr>
-              <a:t>Implementation, validation, and formal experimental evidence</a:t>
+              <a:t>Implementation progress, validation, and initial experimental results</a:t>
             </a:r>
           </a:p>
         </p:txBody>
@@ -12010,7 +12010,7 @@
                   <a:srgbClr val="FFFFFF"/>
                 </a:solidFill>
               </a:rPr>
-              <a:t>2. Should the thesis include only semantic and experimental evaluation, or also an amortized operation-bound argument?</a:t>
+              <a:t>2. Is a tested, semantically equivalent prototype enough, or should I also prove the required amortized operation bounds?</a:t>
             </a:r>
           </a:p>
         </p:txBody>

</xml_diff>

<commit_message>
Clarify validation and runtime wording in progress report notes
</commit_message>
<xml_diff>
--- a/presentations/progress_report/Jordan_Sorting_Progress_Report.pptx
+++ b/presentations/progress_report/Jordan_Sorting_Progress_Report.pptx
@@ -652,7 +652,7 @@
           <a:lstStyle xmlns:a="http://schemas.openxmlformats.org/drawingml/2006/main"/>
           <a:p xmlns:a="http://schemas.openxmlformats.org/drawingml/2006/main">
             <a:r>
-              <a:t>I use four main checks for the implementation. Focused regression cases cover known edge conditions. Exhaustive validation runs all 2,074 oracle-valid permutations up to size eight. Checked-state audits inspect parent links, ownership, sibling lists, and recovered output. Deterministic replay runs the same core again and compares the resulting state. Replay checks consistency. It does not provide a second Jordan-sorting implementation. Separately, an experiment validation path checks that the saved outputs match the fixed setup and recomputed summaries. I keep the detailed archive checks in Backup C because the main research point here is the algorithm state. These checks support the evaluated cases, but they do not prove correctness for every Jordan sequence.</a:t>
+              <a:t>I use four main checks for the implementation. Focused regression cases cover known edge conditions. Bounded exhaustive validation covers all 2,074 oracle-valid permutations up to size eight. Checked-state audits inspect parent links, ownership, sibling lists, and recovered output. Deterministic replay runs the same core again and compares the resulting state. Replay checks consistency. It does not provide a second Jordan-sorting implementation. Separately, an experiment validation path checks that the saved outputs match the fixed setup and recomputed summaries. I keep the detailed archive checks in Backup C because the main research point here is the algorithm state. These checks support the evaluated cases, but they do not prove correctness for every Jordan sequence.</a:t>
             </a:r>
           </a:p>
           <a:p xmlns:a="http://schemas.openxmlformats.org/drawingml/2006/main">
@@ -852,7 +852,7 @@
           <a:lstStyle xmlns:a="http://schemas.openxmlformats.org/drawingml/2006/main"/>
           <a:p xmlns:a="http://schemas.openxmlformats.org/drawingml/2006/main">
             <a:r>
-              <a:t>All 60 evaluated cases passed certification and the case-level checked-state audit. Every measured call returned the expected output, and the run recorded no correctness errors. The experiment used one audit per exact case. Its 3,600 timing rows carry the corresponding case-level audit result, so the row count does not mean 3,600 independent audits. These results support the tested valid cases only. They do not evaluate recognition of arbitrary inputs or prove correctness for every Jordan sequence.</a:t>
+              <a:t>All 60 evaluated cases passed certification and one case-level checked-state audit each. Every measured call returned the expected output, and the run recorded no correctness errors. The experiment used one audit per exact case. Its 3,600 timing rows carry the corresponding case-level audit result, so the row count does not mean 3,600 independent audits. These results support the tested valid cases only. They do not evaluate recognition of arbitrary inputs or prove correctness for every Jordan sequence.</a:t>
             </a:r>
           </a:p>
           <a:p xmlns:a="http://schemas.openxmlformats.org/drawingml/2006/main">
@@ -952,7 +952,7 @@
           <a:lstStyle xmlns:a="http://schemas.openxmlformats.org/drawingml/2006/main"/>
           <a:p xmlns:a="http://schemas.openxmlformats.org/drawingml/2006/main">
             <a:r>
-              <a:t>The main runtime pattern is the decrease in the paper/reference ratio across the five tested sizes. I first compute the ratio for each exact case. Each case then has equal weight in the size-level median. The ratio is 3.226 at n equals 32, 2.202 at 64, and 1.351 at 128. It falls below one at 256, where it is 0.851, and reaches 0.567 at 512. The observed crossover lies between the tested sizes 128 and 256. Under these timing scopes, the recorded paper call is smaller than the reference-pipeline call at the two larger sizes. The scopes differ, so this pattern does not establish a general speedup. Five sizes also do not establish asymptotic behavior. Python sort, shown in Backup A, has the lowest median call time at every tested size.</a:t>
+              <a:t>The main runtime pattern is the decrease in the paper/reference ratio across the five tested sizes. I first compute the ratio for each exact case. Each case then has equal weight in the size-level median. The ratio is 3.226 at n equals 32, 2.202 at 64, and 1.351 at 128. It falls below one at 256, where it is 0.851, and reaches 0.567 at 512. The ratio is above one at n = 128 and below one at n = 256. Under these timing scopes, the recorded paper call is smaller than the reference-pipeline call at the two larger sizes. The scopes differ, so this pattern does not establish a general speedup. Five sizes also do not establish asymptotic behavior. Python sort, shown in Backup A, has the lowest median call time at every tested size.</a:t>
             </a:r>
           </a:p>
           <a:p xmlns:a="http://schemas.openxmlformats.org/drawingml/2006/main">

</xml_diff>

<commit_message>
Shorten bilingual progress report speaker scripts and notes
</commit_message>
<xml_diff>
--- a/presentations/progress_report/Jordan_Sorting_Progress_Report.pptx
+++ b/presentations/progress_report/Jordan_Sorting_Progress_Report.pptx
@@ -462,7 +462,7 @@
           <a:lstStyle xmlns:a="http://schemas.openxmlformats.org/drawingml/2006/main"/>
           <a:p xmlns:a="http://schemas.openxmlformats.org/drawingml/2006/main">
             <a:r>
-              <a:t>Good afternoon. This presentation updates my master's thesis on an executable reconstruction of Simplified Jordan Sorting. My previous report focused on static structure: rank intervals, upper and lower pair families, family trees, and an oracle-backed reference. Since then, I have focused on one question. Can the paper's dynamic procedure run with ordinary Python lists while preserving its own state and recovering its own output? I will explain the reconstruction issues, the checks I used, and the runtime pattern observed in the formal experiment. I will spend most of the time on the two places where the paper description needed an explicit executable decision.</a:t>
+              <a:t>Good afternoon. This presentation updates my master's thesis on an executable reconstruction of Simplified Jordan Sorting using ordinary Python lists. My previous report focused on static structure: rank intervals, upper and lower pair families, family trees, and an oracle-backed reference. The main question is whether the paper's dynamic procedure can maintain its own state and recover its own output. I will focus on two reconstruction decisions, then explain the validation checks and the runtime results from the formal experiment.</a:t>
             </a:r>
           </a:p>
           <a:p xmlns:a="http://schemas.openxmlformats.org/drawingml/2006/main">
@@ -557,7 +557,7 @@
           <a:lstStyle xmlns:a="http://schemas.openxmlformats.org/drawingml/2006/main"/>
           <a:p xmlns:a="http://schemas.openxmlformats.org/drawingml/2006/main">
             <a:r>
-              <a:t>Correct insertion also requires consistent ownership. Every finite pair has one parent and one sibling-list owner. Before a split, the existing owner controls both the retained and acquired segments. After the split, the existing owner keeps the retained segment, and the new owner receives the acquired segment. The split may create new lists for both nonempty sides, but only the acquired segment changes parent. The code treats the split and transfer as one transaction. It saves the affected state, performs the update, and checks the split boundary, ownership, and local postconditions. If a check fails, it restores the old registry, ownership links, and list identifiers. The maintained state also contains the sorted processed prefix and both pair families. Ordinary lists make scanning, copying, slicing, and ownership rebinding visible costs. These checks protect correctness, but they do not provide the update bounds used in the historical linear-time analysis.</a:t>
+              <a:t>Every finite pair has one parent and one sibling-list owner. Before a split, the existing owner controls both the retained and acquired segments. After a split, the original owner keeps the retained segment, while the new owner receives the acquired segment. Both nonempty sides may get new lists, but only the acquired segment changes parent. Split and transfer form one transaction: save the affected state, update it, then check the split boundary, ownership, and local postconditions. If a check fails, rollback restores the registry, ownership links, and list identifiers. The maintained state also contains the sorted processed prefix and both pair families. Ordinary lists incur scanning, copying, slicing, and ownership-rebinding costs. These correctness checks do not establish the update bounds required by the historical linear-time analysis.</a:t>
             </a:r>
           </a:p>
           <a:p xmlns:a="http://schemas.openxmlformats.org/drawingml/2006/main">
@@ -652,7 +652,7 @@
           <a:lstStyle xmlns:a="http://schemas.openxmlformats.org/drawingml/2006/main"/>
           <a:p xmlns:a="http://schemas.openxmlformats.org/drawingml/2006/main">
             <a:r>
-              <a:t>I use four main checks for the implementation. Focused regression cases cover known edge conditions. Bounded exhaustive validation covers all 2,074 oracle-valid permutations up to size eight. Checked-state audits inspect parent links, ownership, sibling lists, and recovered output. Deterministic replay runs the same core again and compares the resulting state. Replay checks consistency. It does not provide a second Jordan-sorting implementation. Separately, an experiment validation path checks that the saved outputs match the fixed setup and recomputed summaries. I keep the detailed archive checks in Backup C because the main research point here is the algorithm state. These checks support the evaluated cases, but they do not prove correctness for every Jordan sequence.</a:t>
+              <a:t>Focused regression cases cover known edge conditions. Bounded exhaustive validation covers all 2,074 oracle-valid permutations up to size eight. Checked-state audits inspect parent links, ownership, sibling lists, and recovered output. Deterministic replay compares states from repeated runs of the same core; it is not a second independent implementation. Replay checks whether the same procedure gives a consistent state. Separate experiment checks compare saved outputs with the fixed setup and recomputed summaries. Backup C gives the details. This finite evidence supports the evaluated cases, but is not a mathematical proof for every Jordan sequence.</a:t>
             </a:r>
           </a:p>
           <a:p xmlns:a="http://schemas.openxmlformats.org/drawingml/2006/main">
@@ -752,7 +752,7 @@
           <a:lstStyle xmlns:a="http://schemas.openxmlformats.org/drawingml/2006/main"/>
           <a:p xmlns:a="http://schemas.openxmlformats.org/drawingml/2006/main">
             <a:r>
-              <a:t>The formal experiment covers five sizes and twelve exact cases per size. It compares three algorithms. Each case-algorithm cell has five warm-up calls and twenty measured calls, producing 3,600 rows. These are repeated calls on the same exact case, not twenty independent inputs. Each call receives a fresh list containing the same values. The schedule rotates algorithm positions so that one method does not always run first. For the paper algorithm, oracle certification and the checked-state audit happen before timing. The minimal paper call runs inside the timer, including output recovery from the maintained order. The runner compares the returned output after timing. Python timing covers its sorting call. Reference timing covers the complete oracle-backed reference pipeline. Paper and reference therefore use different timing scopes, so their ratio is not an end-to-end speedup.</a:t>
+              <a:t>The experiment uses five sizes, twelve exact cases per size, and three algorithms. Each case-algorithm cell has five warm-up calls and twenty measured calls, giving 3,600 measured rows. The twenty calls repeat one exact case; they are not twenty independent inputs. Each call receives a fresh list with the same values. Algorithm positions rotate so that one method does not always run first. Paper certification and the checked-state audit happen before timing. Paper timing includes the minimal core call and output recovery from maintained order. Output comparison follows timing. Python timing covers its sorting call; reference timing covers the complete oracle-backed pipeline. These are three different timing scopes.</a:t>
             </a:r>
           </a:p>
           <a:p xmlns:a="http://schemas.openxmlformats.org/drawingml/2006/main">
@@ -852,7 +852,7 @@
           <a:lstStyle xmlns:a="http://schemas.openxmlformats.org/drawingml/2006/main"/>
           <a:p xmlns:a="http://schemas.openxmlformats.org/drawingml/2006/main">
             <a:r>
-              <a:t>All 60 evaluated cases passed certification and one case-level checked-state audit each. Every measured call returned the expected output, and the run recorded no correctness errors. The experiment used one audit per exact case. Its 3,600 timing rows carry the corresponding case-level audit result, so the row count does not mean 3,600 independent audits. These results support the tested valid cases only. They do not evaluate recognition of arbitrary inputs or prove correctness for every Jordan sequence.</a:t>
+              <a:t>All 60 cases passed certification and one checked-state audit each. Every measured call returned the expected output, with no recorded correctness errors. The 3,600 measured rows carry their case-level audit results; they do not represent 3,600 independent audits. These results cover the tested valid cases only.</a:t>
             </a:r>
           </a:p>
           <a:p xmlns:a="http://schemas.openxmlformats.org/drawingml/2006/main">
@@ -952,7 +952,7 @@
           <a:lstStyle xmlns:a="http://schemas.openxmlformats.org/drawingml/2006/main"/>
           <a:p xmlns:a="http://schemas.openxmlformats.org/drawingml/2006/main">
             <a:r>
-              <a:t>The main runtime pattern is the decrease in the paper/reference ratio across the five tested sizes. I first compute the ratio for each exact case. Each case then has equal weight in the size-level median. The ratio is 3.226 at n equals 32, 2.202 at 64, and 1.351 at 128. It falls below one at 256, where it is 0.851, and reaches 0.567 at 512. The ratio is above one at n = 128 and below one at n = 256. Under these timing scopes, the recorded paper call is smaller than the reference-pipeline call at the two larger sizes. The scopes differ, so this pattern does not establish a general speedup. Five sizes also do not establish asymptotic behavior. Python sort, shown in Backup A, has the lowest median call time at every tested size.</a:t>
+              <a:t>I compute the paper/reference ratio for each exact case, then take the median at each size with equal weight per case. The ratios are 3.226 at n equals 32, 2.202 at 64, 1.351 at 128, 0.851 at 256, and 0.567 at 512. Thus, the ratio is above one at 128 and below one at 256. Paper calls take less time at the two larger sizes under these scopes. Since the scopes differ, this does not establish an end-to-end speedup. Python sort has the lowest median call time at every tested size, as shown in Backup A.</a:t>
             </a:r>
           </a:p>
           <a:p xmlns:a="http://schemas.openxmlformats.org/drawingml/2006/main">
@@ -1047,7 +1047,7 @@
           <a:lstStyle xmlns:a="http://schemas.openxmlformats.org/drawingml/2006/main"/>
           <a:p xmlns:a="http://schemas.openxmlformats.org/drawingml/2006/main">
             <a:r>
-              <a:t>The current evidence supports an executable ordinary-list reconstruction whose output comes from maintained state. It also supports correct output on the evaluated valid cases and a recorded runtime trend under the stated timing scopes. The main limits are equally important. Ordinary Python lists do not establish a linear-time implementation, and five tested sizes do not establish asymptotic complexity. Recognition was not evaluated. The paper/reference comparison still uses different timing scopes. I therefore present the runtime values as observations for this implementation and experiment, not as a general algorithmic bound.</a:t>
+              <a:t>The evidence supports an executable ordinary-list reconstruction that recovers output from maintained state, with correct results on the evaluated cases. The runtime trend describes this implementation under the stated timing scopes. Ordinary lists do not establish a linear-time implementation, and five tested sizes do not establish asymptotic complexity. Recognition was not evaluated.</a:t>
             </a:r>
           </a:p>
           <a:p xmlns:a="http://schemas.openxmlformats.org/drawingml/2006/main">
@@ -1142,7 +1142,7 @@
           <a:lstStyle xmlns:a="http://schemas.openxmlformats.org/drawingml/2006/main"/>
           <a:p xmlns:a="http://schemas.openxmlformats.org/drawingml/2006/main">
             <a:r>
-              <a:t>A possible next step is to investigate a finger-tree backend while keeping the same Step 1, Step 2, and Step 3 behavior. The ordinary-list implementation gives a tested reference point for that work. The detailed backend boundary appears in Backup E, including the ownership-transfer difficulty. I would like guidance on two questions. First, should the extension target the historical heterogeneous finger tree, or an equivalent backend with the required list operations? Second, is a tested, semantically equivalent prototype enough, or should I also prove the required amortized operation bounds? The answer determines whether this stays an implementation experiment or also needs a complexity proof.</a:t>
+              <a:t>A finger-tree backend is a possible future extension, outside the current experimental evidence. It would keep the same Step 1, Step 2, and Step 3 behavior. The ordinary-list implementation provides a tested reference point for checking the behavior of a new backend. Backup E explains the interface and ownership-transfer difficulty. I would like guidance on two questions. Should I target the historical heterogeneous finger tree, or an equivalent backend supporting the required list operations? Is a tested, semantically equivalent prototype enough, or should I also prove the required amortized operation bounds?</a:t>
             </a:r>
           </a:p>
           <a:p xmlns:a="http://schemas.openxmlformats.org/drawingml/2006/main">
@@ -1527,7 +1527,7 @@
           <a:lstStyle xmlns:a="http://schemas.openxmlformats.org/drawingml/2006/main"/>
           <a:p xmlns:a="http://schemas.openxmlformats.org/drawingml/2006/main">
             <a:r>
-              <a:t>The earlier implementation made the static structure explicit. It represented rank intervals, separated the upper and lower families, rebuilt their laminar family trees, and computed structural metrics. The oracle checked whether an input was valid and supplied a reference answer. However, the code did not yet execute the dynamic procedure. It did not update the processed prefix as new points arrived. It also did not split sibling lists, transfer ownership, or recover the final order from the algorithm's own state. These operations matter because an error in one update can corrupt both the partial order and the family structure. The main gap was therefore the move from a structural description to safe dynamic updates.</a:t>
+              <a:t>The previous implementation represented rank intervals, separated upper and lower pair families, rebuilt their laminar family trees, and computed structural metrics. An oracle checked input validity and supplied a reference answer. The missing part was the dynamic procedure: updating the processed prefix, splitting sibling lists, transferring ownership, and recovering output from maintained state. Each update must preserve both the partial order and the family structure. An error in one update can corrupt both, so safe dynamic updates were the main implementation gap.</a:t>
             </a:r>
           </a:p>
           <a:p xmlns:a="http://schemas.openxmlformats.org/drawingml/2006/main">
@@ -1822,7 +1822,7 @@
           <a:lstStyle xmlns:a="http://schemas.openxmlformats.org/drawingml/2006/main"/>
           <a:p xmlns:a="http://schemas.openxmlformats.org/drawingml/2006/main">
             <a:r>
-              <a:t>Since the previous report, I have worked on four areas. I first narrowed the scope to sorting inputs that an external oracle has already certified. I then implemented the Step 1, Step 2, and Step 3 control flow. Next, I added ownership checks, transactional updates, replay, and bounded validation. Finally, after the implementation was working and checked, I ran a formal experiment with a fixed protocol. The result is an executable ordinary-list implementation. The specialized backend used in the historical linear-time analysis remains future work.</a:t>
+              <a:t>Since then, I narrowed the scope to externally certified valid inputs and implemented the Step 1, Step 2, and Step 3 control flow. I added ownership checks, transactional updates, replay, and bounded validation. Once the implementation passed these checks, I ran a formal experiment with a fixed protocol. The result is an executable ordinary-list reconstruction.</a:t>
             </a:r>
           </a:p>
           <a:p xmlns:a="http://schemas.openxmlformats.org/drawingml/2006/main">
@@ -1917,7 +1917,7 @@
           <a:lstStyle xmlns:a="http://schemas.openxmlformats.org/drawingml/2006/main"/>
           <a:p xmlns:a="http://schemas.openxmlformats.org/drawingml/2006/main">
             <a:r>
-              <a:t>As the implementation became clearer, I narrowed the scope. The thesis now studies the 1990 sorting procedure on inputs that an oracle has already certified as valid. The experiment compares Python sort, the complete oracle-backed reference pipeline, and the reconstructed paper core. Recognition remains a separate question. I do not use the experiment to classify invalid inputs. The paper core also uses ordinary Python lists rather than the specialized historical backend. This scope lets the thesis study one concrete issue: whether the dynamic procedure can run correctly and recover output from its own maintained state. A finger-tree backend remains a possible extension.</a:t>
+              <a:t>The thesis studies the 1990 sorting procedure on inputs already certified as valid by an oracle. The experiment compares Python sort, the complete oracle-backed reference pipeline, and the reconstructed paper core. Recognition remains outside this experiment. The current core uses ordinary Python lists. It does not implement the specialized backend used in the historical linear-time analysis.</a:t>
             </a:r>
           </a:p>
           <a:p xmlns:a="http://schemas.openxmlformats.org/drawingml/2006/main">
@@ -2017,7 +2017,7 @@
           <a:lstStyle xmlns:a="http://schemas.openxmlformats.org/drawingml/2006/main"/>
           <a:p xmlns:a="http://schemas.openxmlformats.org/drawingml/2006/main">
             <a:r>
-              <a:t>The work has three research questions. RQ1 asks whether the ordinary-list reconstruction can recover the correct sorted order from its maintained state on certified valid inputs. RQ2 asks how the paper call behaves relative to Python sort and the complete reference pipeline under their stated timing scopes. RQ3 looks for descriptive relationships between input structure, checked operation counters, and runtime. These questions keep reconstruction, measurement, and interpretation separate. RQ1 is the main technical question. RQ2 reports measured behavior. RQ3 remains exploratory and does not claim a causal explanation.</a:t>
+              <a:t>RQ1 is the main technical question: can the ordinary-list reconstruction recover the correct sorted order from maintained state on certified valid inputs? RQ2 compares the paper call with Python sort and the complete reference pipeline under their stated timing scopes. RQ3 explores descriptive relationships between input structure, checked operation counters, and runtime. It does not claim a causal explanation.</a:t>
             </a:r>
           </a:p>
           <a:p xmlns:a="http://schemas.openxmlformats.org/drawingml/2006/main">
@@ -2102,7 +2102,7 @@
           <a:lstStyle xmlns:a="http://schemas.openxmlformats.org/drawingml/2006/main"/>
           <a:p xmlns:a="http://schemas.openxmlformats.org/drawingml/2006/main">
             <a:r>
-              <a:t>The oracle, reference pipeline, and paper core play different roles. Before the paper call, the oracle checks the valid-input condition. After the call, the runner uses the oracle's sorted result as the expected answer. The reference pipeline intentionally consumes the complete oracle result, including that sorted output. The paper core receives only the original sequence under the certified precondition. It runs Step 1, Step 2, and Step 3, updates its partial order and sibling-list state, and returns the order recovered from that state. The dashed comparison box sits outside the paper core. Both methods are checked against the same expected answer, but they produce their outputs differently. This distinction lets me test the paper core without supplying the answer as input. The oracle-sorted list never enters the paper core and never determines its return value.</a:t>
+              <a:t>Before the paper call, the oracle certifies input validity. After the call, the runner compares the returned output with the oracle's sorted result. The reference pipeline uses the complete oracle result, including that sorted output. The paper core receives only the original sequence under the certified precondition. It executes Step 1, Step 2, and Step 3, maintains the partial order and sibling lists, and recovers output from the partial order. Both methods are checked against the same expected answer, but they produce their outputs differently. The oracle-sorted answer never enters the paper core. The dashed comparison box therefore sits outside it.</a:t>
             </a:r>
           </a:p>
           <a:p xmlns:a="http://schemas.openxmlformats.org/drawingml/2006/main">
@@ -2202,7 +2202,7 @@
           <a:lstStyle xmlns:a="http://schemas.openxmlformats.org/drawingml/2006/main"/>
           <a:p xmlns:a="http://schemas.openxmlformats.org/drawingml/2006/main">
             <a:r>
-              <a:t>The reconstruction follows one control-flow skeleton. It first orders z one, z two, and z three, then initializes the partial order and the first upper and lower pairs. After that, each new point passes through Step 1, Step 2, and Step 3. Step 1 finds the predecessor boundary, which I call A sub i. Step 2 finds the successor boundary, B sub i. Step 3(a) inserts the new pair. Step 3(b) performs any required sibling-list split and ownership transfer. Step 3(c) inserts the new point into the maintained order. The increasing and decreasing cases share these stages. Their local roles are reflected. In an increasing iteration, Step 3(a) uses A sub i and Step 3(b) uses B sub i. A decreasing iteration swaps those uses. The 1990 paper states the increasing case, while the decreasing case follows by symmetry. Two operational details still need explicit rules in code: the geometric endpoint and the odd-index z one output anchor. The next two slides explain why those choices matter.</a:t>
+              <a:t>The procedure first orders z one, z two, and z three, then initializes the partial order and the first upper and lower pairs. For each new point, Step 1 finds predecessor boundary pair A sub i, and Step 2 finds successor boundary pair B sub i. Step 3(a) inserts a pair. Step 3(b) splits a sibling list and transfers ownership when needed. These steps update the pair families. Step 3(c) inserts the point into the maintained order. In an increasing iteration, Step 3(a) uses A sub i and Step 3(b) uses B sub i. A decreasing iteration swaps these uses. The paper states the increasing case; the decreasing case follows by symmetry. The two orientations share the same stages, but reflect the local roles. The next slides explain two executable clarifications: the geometric endpoint and the odd-index z one output anchor.</a:t>
             </a:r>
           </a:p>
           <a:p xmlns:a="http://schemas.openxmlformats.org/drawingml/2006/main">
@@ -2297,7 +2297,7 @@
           <a:lstStyle xmlns:a="http://schemas.openxmlformats.org/drawingml/2006/main"/>
           <a:p xmlns:a="http://schemas.openxmlformats.org/drawingml/2006/main">
             <a:r>
-              <a:t>The first issue concerns the endpoint used in Step 3(c). Consider the valid prefix three, two, one, four. The acquired pair P two is stored in curve order as three, two. A mechanical reading might choose the second stored element, two, as the insertion anchor. That produces one, two, four, three, which is wrong on the axis. Curve order and axis order describe different things. The pair records traversal along the curve, while Step 3(c) needs the geometric extreme on the axis. Here the correct endpoint is three. Inserting four after three gives one, two, three, four. This is a representation issue, not a special case for these four numbers. The stored pair order follows the curve, so its second item does not always represent the required side of the current axis order. The increasing orientation uses the right geometric endpoint, and the decreasing orientation uses the left endpoint. I describe this as an executable clarification because the 1990 paper does not state it in this form. Without the clarification, valid examples fail.</a:t>
+              <a:t>Consider the valid prefix three, two, one, four. The acquired pair P two is stored in curve order as three, two. Using its second stored element, two, as the anchor gives one, two, four, three, which is wrong on the axis. Step 3(c) needs the geometric extreme, not the second element in curve order. Here the correct anchor is three. Inserting four after three gives one, two, three, four. The pair records traversal along the curve, while insertion must follow the axis order. This is a representation issue: curve order does not always identify the required side of the axis order. Increasing iterations use the right geometric endpoint; decreasing iterations use the left. This is an executable clarification, since the 1990 paper does not state the rule in this form. Without this clarification, even valid examples fail.</a:t>
             </a:r>
           </a:p>
           <a:p xmlns:a="http://schemas.openxmlformats.org/drawingml/2006/main">
@@ -2387,7 +2387,7 @@
           <a:lstStyle xmlns:a="http://schemas.openxmlformats.org/drawingml/2006/main"/>
           <a:p xmlns:a="http://schemas.openxmlformats.org/drawingml/2006/main">
             <a:r>
-              <a:t>The second issue is the odd-index z one case. The valid prefix here is one, two, three, four, six, seven, zero. During this decreasing iteration, the ordinary geometric base anchor is z two, with value two. Inserting zero directly before z two gives one, zero, two, three, four, six, seven. Z one remains on the wrong side of the new point. Zero is smaller than z one. Z one is also smaller than the original anchor. Therefore, the output anchor changes from z two to z one. Inserting zero before z one gives the correct order. The important point is that this change affects the output insertion only. It does not replace the earlier predecessor or successor boundary calculation. Those two decisions solve different problems. One selects the pair used by the family update. The other selects the point used to update the output order. The implementation records both decisions separately, which also makes the diagnostic trace easier to check.</a:t>
+              <a:t>The odd-index z one case uses the valid prefix one, two, three, four, six, seven, zero. In this decreasing iteration, the ordinary anchor is z two, with value two. Inserting zero before it gives one, zero, two, three, four, six, seven. Z one remains on the wrong side of the new point. Here zero is smaller than z one, and z one is smaller than the original anchor. The output anchor must therefore change to z one. Inserting zero before z one gives zero, one, two, three, four, six, seven. This correction changes only output insertion. It does not replace the earlier predecessor or successor boundary calculation. Boundary selection still chooses the pair for the family update; the output anchor chooses the point for insertion into the partial order.</a:t>
             </a:r>
           </a:p>
           <a:p xmlns:a="http://schemas.openxmlformats.org/drawingml/2006/main">

</xml_diff>

<commit_message>
Restore slide 9 note sources and clarify decreasing wording
</commit_message>
<xml_diff>
--- a/presentations/progress_report/Jordan_Sorting_Progress_Report.pptx
+++ b/presentations/progress_report/Jordan_Sorting_Progress_Report.pptx
@@ -3005,7 +3005,7 @@
             </a:pPr>
             <a:r>
               <a:rPr/>
-              <a:t>Here we insert zero at iteration seven. The odd index makes the new pair a lower pair. Zero below seven makes this iteration decreasing. After Step three B, the new pair has children P three and P five, shown here. Step three C takes the left endpoint of the leftmost child, P three, with endpoints two and three. So the base anchor is two. However, z one, with value one, is not an endpoint of any lower pair. It is still in the sorted list. Inserting zero before two would leave zero after one. Here the index is odd, and zero is smaller than z one, which is smaller than the base anchor. We therefore change the anchor to z one. This changes only output insertion, not the earlier boundary-pair selection.</a:t>
+              <a:t>Here we insert zero at iteration seven. The odd index makes the new pair a lower pair. Since zero is less than seven, this iteration is decreasing. After Step three B, the new pair has children P three and P five, shown here. Step three C takes the left endpoint of the leftmost child, P three, with endpoints two and three. So the base anchor is two. However, z one, with value one, is not an endpoint of any lower pair. It is still in the sorted list. Inserting zero before two would leave zero after one. Here the index is odd, and zero is smaller than z one, which is smaller than the base anchor. We therefore change the anchor to z one. This changes only output insertion, not the earlier boundary-pair selection.</a:t>
             </a:r>
             <a:endParaRPr/>
           </a:p>
@@ -3014,6 +3014,11 @@
               <a:defRPr/>
             </a:pPr>
             <a:endParaRPr/>
+          </a:p>
+          <a:p>
+            <a:r>
+              <a:t>中文参考</a:t>
+            </a:r>
           </a:p>
           <a:p>
             <a:pPr>
@@ -3031,6 +3036,27 @@
               <a:t>这里在第 7 次迭代插入 0。结束下标为奇数，因此新 pair 属于 lower family；0 小于旧端点 7，因此本次为 decreasing。Step 3(b) 后，新 pair 获得图中的 P₃ 和 P₅。Step 3(c) 取最左 child P₃ 的几何左端点。P₃ 的端点为 2 和 3，所以 base anchor 是 2。但是 z₁ 的值为 1，它不是任何 lower pair 的端点，却仍在有序列表中。若直接把 0 插在 2 前，会让 0 留在 1 后面。本例下标为奇数，且 0 小于 z₁，z₁ 又小于 base anchor，因此最终 anchor 改为 z₁。这只改变输出插入，不替代先前的 boundary-pair selection。</a:t>
             </a:r>
             <a:endParaRPr/>
+          </a:p>
+          <a:p/>
+          <a:p>
+            <a:r>
+              <a:t>[Sources]</a:t>
+            </a:r>
+          </a:p>
+          <a:p>
+            <a:r>
+              <a:t>- thesis/chapters/algorithm.tex</a:t>
+            </a:r>
+          </a:p>
+          <a:p>
+            <a:r>
+              <a:t>- thesis/figures/step3c_anchor_z1_anomaly.pdf</a:t>
+            </a:r>
+          </a:p>
+          <a:p>
+            <a:r>
+              <a:t>- Hoffmann et al. (1986), p. 175, doi:10.1016/S0019-9958(86)80033-X</a:t>
+            </a:r>
           </a:p>
         </p:txBody>
       </p:sp>

</xml_diff>

<commit_message>
Explain the two maintained states and slide 7 step purposes
</commit_message>
<xml_diff>
--- a/presentations/progress_report/Jordan_Sorting_Progress_Report.pptx
+++ b/presentations/progress_report/Jordan_Sorting_Progress_Report.pptx
@@ -2743,7 +2743,7 @@
             </a:pPr>
             <a:r>
               <a:rPr/>
-              <a:t>We initialize once. The core sorts only the first three points by x-coordinate to build S three and the upper and lower pair families. It uses no oracle answer. Labels and stored pair endpoints keep curve order. From point four onward, each round adds one point. Steps one and two inspect the neighbors of z i minus one in S i minus one. They do not simply take z i minus two or first locate the new point. They find predecessor boundary A sub i and successor boundary B sub i. Step three A inserts the new pair. Step three B splits sibling lists and transfers ownership when needed. Step three C inserts the new point into the sorted list. Increasing Step three A uses A sub i, and three B uses B sub i. Decreasing swaps these uses and reflects left and right operations. Steps one and two still return A and B. The paper explicitly states the increasing case. Decreasing is a symmetric reconstruction; anchor details are executable clarifications. These categories do not correspond to separate steps. The next two slides explain the anchor clarifications.</a:t>
+              <a:t>We maintain two things: the sorted order of the processed points, and the parent-child structure of the pairs. We initialize once, sorting only the first three points by x-coordinate. Their sorted order is called S three. We also initialize the upper and lower pair families, without an oracle answer. Point labels and stored pair endpoints keep curve order. Starting with point four, each round adds one point. We start from the previous point along the curve. Steps one and two use its neighbors in the sorted list to find predecessor boundary A sub i and successor boundary B sub i. Step three A places the new pair in the family structure and assigns its parent. Step three B splits a sibling list when needed, so newly enclosed pairs become children of the new pair. Only then does Step three C insert the new point into the sorted list, using an anchor selected from the maintained state. Increasing Step three A uses A sub i, and three B uses B sub i. Decreasing swaps these uses and reflects left and right operations. Steps one and two still return A and B. The paper states the increasing case. Decreasing is a symmetric reconstruction; anchor details are executable clarifications. These categories describe the basis of the reconstruction, not separate steps.</a:t>
             </a:r>
             <a:endParaRPr/>
           </a:p>
@@ -2765,7 +2765,7 @@
                 <a:ea typeface="+mn-ea"/>
                 <a:cs typeface="+mn-cs"/>
               </a:rPr>
-              <a:t>初始化只做一次。Core 仅将前三个点按 x 坐标排序，建立 S₃ 和 upper、lower pair family，不使用 oracle 的排序答案。点的编号和 pair 的端点存储仍保持曲线顺序。从第 4 个点开始，每轮加入一个新点。Step 1、2 查看旧端点 zᵢ₋₁ 在维护列表中的邻居，不是直接取前一个曲线点 zᵢ₋₂，也不是先查新点的排序位置。它们分别找到 predecessor boundary Aᵢ 和 successor boundary Bᵢ。Step 3(a) 插入新 pair；Step 3(b) 在需要时拆分 sibling list 并转移 ownership；Step 3(c) 将新点插入有序列表。Increasing 时，Step 3(a) 使用 Aᵢ，3(b) 使用 Bᵢ。Decreasing 交换这两者的用途，并镜像左右操作；Step 1、2 仍分别返回 Aᵢ、Bᵢ。论文明确描述 increasing 情形；decreasing 来自对称重构，anchor 的细节属于可执行化澄清。这三个类别并不分别对应某个步骤。接下来两页解释 anchor 的澄清。</a:t>
+              <a:t>我们同时维护两种信息：已处理点的排序，以及 pairs 之间的父子关系。初始化只做一次，仅将前三个点按 x 坐标排序，这个有序列表称为 S₃。同时建立 upper、lower pair family，不使用 oracle 的排序答案。点的编号和 pair 的端点存储仍保持曲线顺序。从第 4 个点开始，每轮加入一个新点。我们从沿曲线的前一个点出发。Step 1、2 利用它在有序列表中的邻居，分别找到 predecessor boundary Aᵢ 和 successor boundary Bᵢ。Step 3(a) 将新 pair 放入 family 结构，并确定它的 parent。Step 3(b) 在需要时拆分 sibling list，让新包含的旧 pairs 成为新 pair 的 children。到这时，Step 3(c) 才根据维护的状态选择 anchor，将新点插入有序列表。Increasing 时，Step 3(a) 使用 Aᵢ，3(b) 使用 Bᵢ。Decreasing 交换两者的用途，并镜像左右操作；Step 1、2 仍分别返回 Aᵢ、Bᵢ。论文描述 increasing 情形；decreasing 来自对称重构，anchor 的细节属于可执行化澄清。这些类别说明重构的依据，并不分别对应某个步骤。</a:t>
             </a:r>
             <a:endParaRPr sz="1200"/>
           </a:p>

</xml_diff>

<commit_message>
Clarify slide 14 ratio trend and limits of cost attribution
</commit_message>
<xml_diff>
--- a/presentations/progress_report/Jordan_Sorting_Progress_Report.pptx
+++ b/presentations/progress_report/Jordan_Sorting_Progress_Report.pptx
@@ -1237,44 +1237,195 @@
         <p:txBody>
           <a:bodyPr/>
           <a:lstStyle/>
-          <a:p>
-            <a:pPr>
-              <a:defRPr/>
-            </a:pPr>
-            <a:r>
-              <a:rPr/>
-              <a:t>For each case, I divide the median paper time by the median reference time. I then take the median of these ratios for each size. The ratios are 3.226 at n equals 32, 2.202 at 64, 1.351 at 128, 0.851 at 256, and 0.567 at 512. Thus, the ratio is above one at 128 and below one at 256. Paper calls take less time at the two larger sizes under these scopes. Since the scopes differ, this does not establish an end-to-end speedup. Python sort has the lowest median call time at every tested size, as shown in Backup A.</a:t>
-            </a:r>
-            <a:endParaRPr/>
-          </a:p>
-          <a:p>
-            <a:pPr>
-              <a:defRPr/>
-            </a:pPr>
-            <a:endParaRPr/>
-          </a:p>
-          <a:p>
-            <a:pPr>
-              <a:defRPr/>
-            </a:pPr>
-            <a:r>
-              <a:rPr lang="en-US" sz="1200" b="0" i="0" u="none" strike="noStrike" cap="none" spc="0">
-                <a:solidFill>
-                  <a:srgbClr val="000000"/>
-                </a:solidFill>
-                <a:latin typeface="+mn-lt"/>
-                <a:ea typeface="+mn-ea"/>
-                <a:cs typeface="+mn-cs"/>
-              </a:rPr>
-              <a:t>对每个 case，我用 paper 调用时间的中位数除以 reference 调用时间的中位数。然后对每个规模下的这些比值取中位数。比值在 n 为 32 时是 3.226，64 时是 2.202，128 时是 1.351，256 时是 0.851，512 时是 0.567。因此，128 时比值大于 1，256 时小于 1。在这些计时范围下，两个较大规模的 paper 调用耗时更少。由于计时范围不同，这不能证明端到端加速。Python sort 在每个测试规模上都有最低的调用时间中位数，见 Backup A。</a:t>
-            </a:r>
-            <a:endParaRPr sz="1200"/>
-          </a:p>
-          <a:p>
-            <a:pPr>
-              <a:defRPr/>
-            </a:pPr>
-            <a:endParaRPr/>
+          <a:p xmlns:a="http://schemas.openxmlformats.org/drawingml/2006/main">
+            <a:r>
+              <a:t>For each exact case, I divide the median of twenty paper times by the median of twenty reference times. I then take the median of these ratios for each input size, with equal weight per case.</a:t>
+            </a:r>
+          </a:p>
+          <a:p xmlns:a="http://schemas.openxmlformats.org/drawingml/2006/main">
+            <a:r>
+              <a:t/>
+            </a:r>
+          </a:p>
+          <a:p xmlns:a="http://schemas.openxmlformats.org/drawingml/2006/main">
+            <a:r>
+              <a:t>The ratio falls from 3.226 at 32 points to 2.202 at 64, 1.351 at 128, 0.851 at 256, and 0.567 at 512. It is above one at 128 and below one at 256.</a:t>
+            </a:r>
+          </a:p>
+          <a:p xmlns:a="http://schemas.openxmlformats.org/drawingml/2006/main">
+            <a:r>
+              <a:t/>
+            </a:r>
+          </a:p>
+          <a:p xmlns:a="http://schemas.openxmlformats.org/drawingml/2006/main">
+            <a:r>
+              <a:t>In the reported size-level summaries, both median call times increase across these tested sizes, but the reference time grows more rapidly.</a:t>
+            </a:r>
+          </a:p>
+          <a:p xmlns:a="http://schemas.openxmlformats.org/drawingml/2006/main">
+            <a:r>
+              <a:t/>
+            </a:r>
+          </a:p>
+          <a:p xmlns:a="http://schemas.openxmlformats.org/drawingml/2006/main">
+            <a:r>
+              <a:t>One possible contributor is the oracle's interval checks. For these valid inputs, it compares every pair of intervals within each family. The number of these checks grows quadratically. This work is included in reference timing, while the paper input is certified before timing. Paper initialization, Steps one to three, and output recovery remain timed.</a:t>
+            </a:r>
+          </a:p>
+          <a:p xmlns:a="http://schemas.openxmlformats.org/drawingml/2006/main">
+            <a:r>
+              <a:t/>
+            </a:r>
+          </a:p>
+          <a:p xmlns:a="http://schemas.openxmlformats.org/drawingml/2006/main">
+            <a:r>
+              <a:t>The current measurements do not isolate this cost, so its contribution to the trend is not confirmed.</a:t>
+            </a:r>
+          </a:p>
+          <a:p xmlns:a="http://schemas.openxmlformats.org/drawingml/2006/main">
+            <a:r>
+              <a:t/>
+            </a:r>
+          </a:p>
+          <a:p xmlns:a="http://schemas.openxmlformats.org/drawingml/2006/main">
+            <a:r>
+              <a:t>These are different timing scopes, not a like-for-like end-to-end speedup or evidence of linear time. Python sort still has the lowest median call time at every tested size.</a:t>
+            </a:r>
+          </a:p>
+          <a:p xmlns:a="http://schemas.openxmlformats.org/drawingml/2006/main">
+            <a:r>
+              <a:t/>
+            </a:r>
+          </a:p>
+          <a:p xmlns:a="http://schemas.openxmlformats.org/drawingml/2006/main">
+            <a:r>
+              <a:t>[中文参考]</a:t>
+            </a:r>
+          </a:p>
+          <a:p xmlns:a="http://schemas.openxmlformats.org/drawingml/2006/main">
+            <a:r>
+              <a:t>对每个 exact case，我用 20 次 paper 调用耗时的中位数除以 20 次 reference 调用耗时的中位数。然后对同一输入规模下的这些比值取中位数，每个 case 权重相同。</a:t>
+            </a:r>
+          </a:p>
+          <a:p xmlns:a="http://schemas.openxmlformats.org/drawingml/2006/main">
+            <a:r>
+              <a:t/>
+            </a:r>
+          </a:p>
+          <a:p xmlns:a="http://schemas.openxmlformats.org/drawingml/2006/main">
+            <a:r>
+              <a:t>比值从 32 个点时的 3.226，下降到 64 时的 2.202、128 时的 1.351、256 时的 0.851，以及 512 时的 0.567。128 时比值仍大于 1，256 时已经小于 1。</a:t>
+            </a:r>
+          </a:p>
+          <a:p xmlns:a="http://schemas.openxmlformats.org/drawingml/2006/main">
+            <a:r>
+              <a:t/>
+            </a:r>
+          </a:p>
+          <a:p xmlns:a="http://schemas.openxmlformats.org/drawingml/2006/main">
+            <a:r>
+              <a:t>在已报告的规模级汇总中，两种调用的中位耗时都随这些测试规模增加，但 reference 的耗时增长更快。</a:t>
+            </a:r>
+          </a:p>
+          <a:p xmlns:a="http://schemas.openxmlformats.org/drawingml/2006/main">
+            <a:r>
+              <a:t/>
+            </a:r>
+          </a:p>
+          <a:p xmlns:a="http://schemas.openxmlformats.org/drawingml/2006/main">
+            <a:r>
+              <a:t>一个可能的贡献因素是 oracle 的区间检查。对于这些有效输入，它会在每个 family 内逐对比较所有区间。这些检查的次数呈二次增长。这项工作包含在 reference 计时内，而 paper 输入在计时前完成认证。Paper 的初始化、Step 1 至 3 和输出恢复仍在计时内。</a:t>
+            </a:r>
+          </a:p>
+          <a:p xmlns:a="http://schemas.openxmlformats.org/drawingml/2006/main">
+            <a:r>
+              <a:t/>
+            </a:r>
+          </a:p>
+          <a:p xmlns:a="http://schemas.openxmlformats.org/drawingml/2006/main">
+            <a:r>
+              <a:t>当前测量没有单独隔离这项成本，因此尚未确认它对该趋势的贡献。</a:t>
+            </a:r>
+          </a:p>
+          <a:p xmlns:a="http://schemas.openxmlformats.org/drawingml/2006/main">
+            <a:r>
+              <a:t/>
+            </a:r>
+          </a:p>
+          <a:p xmlns:a="http://schemas.openxmlformats.org/drawingml/2006/main">
+            <a:r>
+              <a:t>这些是不同的计时范围，不能视为同口径的端到端加速，也不是线性时间的证据。Python sort 在每个测试规模上仍有最低的调用时间中位数。</a:t>
+            </a:r>
+          </a:p>
+          <a:p xmlns:a="http://schemas.openxmlformats.org/drawingml/2006/main">
+            <a:r>
+              <a:t/>
+            </a:r>
+          </a:p>
+          <a:p xmlns:a="http://schemas.openxmlformats.org/drawingml/2006/main">
+            <a:r>
+              <a:t>[Sources]</a:t>
+            </a:r>
+          </a:p>
+          <a:p xmlns:a="http://schemas.openxmlformats.org/drawingml/2006/main">
+            <a:r>
+              <a:t>- thesis/chapters/results.tex</a:t>
+            </a:r>
+          </a:p>
+          <a:p xmlns:a="http://schemas.openxmlformats.org/drawingml/2006/main">
+            <a:r>
+              <a:t>- results/runs/week12_formal_sorting_v1__run001/case_summary.csv</a:t>
+            </a:r>
+          </a:p>
+          <a:p xmlns:a="http://schemas.openxmlformats.org/drawingml/2006/main">
+            <a:r>
+              <a:t>- docs/analysis/week12_runtime_ratios.csv</a:t>
+            </a:r>
+          </a:p>
+          <a:p xmlns:a="http://schemas.openxmlformats.org/drawingml/2006/main">
+            <a:r>
+              <a:t>- thesis/chapters/methodology.tex</a:t>
+            </a:r>
+          </a:p>
+          <a:p xmlns:a="http://schemas.openxmlformats.org/drawingml/2006/main">
+            <a:r>
+              <a:t>- results/runs/week12_formal_sorting_v1__run001/config.json</a:t>
+            </a:r>
+          </a:p>
+          <a:p xmlns:a="http://schemas.openxmlformats.org/drawingml/2006/main">
+            <a:r>
+              <a:t>- results/runs/week12_formal_sorting_v1__run001/manifest.json (source_commit: 98868b1b705f6d5f22404ee8ad7b88ad7a834f52; all source-code mechanisms below checked at this revision)</a:t>
+            </a:r>
+          </a:p>
+          <a:p xmlns:a="http://schemas.openxmlformats.org/drawingml/2006/main">
+            <a:r>
+              <a:t>- src/oracle.py</a:t>
+            </a:r>
+          </a:p>
+          <a:p xmlns:a="http://schemas.openxmlformats.org/drawingml/2006/main">
+            <a:r>
+              <a:t>- src/simplified_jordan.py</a:t>
+            </a:r>
+          </a:p>
+          <a:p xmlns:a="http://schemas.openxmlformats.org/drawingml/2006/main">
+            <a:r>
+              <a:t>- experiments/run_week11_pilot.py (run_timed_algorithm, _time_once_algorithm)</a:t>
+            </a:r>
+          </a:p>
+          <a:p xmlns:a="http://schemas.openxmlformats.org/drawingml/2006/main">
+            <a:r>
+              <a:t>- experiments/run_week12_formal_sorting.py (build_cases_and_audits, make_raw_rows)</a:t>
+            </a:r>
+          </a:p>
+          <a:p xmlns:a="http://schemas.openxmlformats.org/drawingml/2006/main">
+            <a:r>
+              <a:t>- src/paper_jordan_sort.py</a:t>
+            </a:r>
+          </a:p>
+          <a:p xmlns:a="http://schemas.openxmlformats.org/drawingml/2006/main">
+            <a:r>
+              <a:t>- src/paper_jordan.py</a:t>
+            </a:r>
           </a:p>
         </p:txBody>
       </p:sp>

</xml_diff>